<commit_message>
refactor: 광고가 전면 제거 (S01/S01b/S02 + 백엔드)
- 백엔드: search 분류에서 광고 제거(내/일반 2열)·매매가=팀 sale_price · extras 광고가 엔드포인트 삭제 · series 광고 kind 제거
- S01: 광고열→내/일반 2열, 지도 범례·태그·CSS 2열, adPrices/PriceTrend 광고선 제거
- S01b: 광고가·광고 상승률·광고 상태 필터 제거
- S02: 시세추이 광고가 카드·업무탭 '내 광고' 제거, MarketTrend/series 광고 제거
- 지도 핀 색: 광고(green) 제거 → 내(blue)/일반(purple)

Co-Authored-By: Claude Opus 4.8 <noreply@anthropic.com>
</commit_message>
<xml_diff>
--- a/specs/03-features/R_example.pptx
+++ b/specs/03-features/R_example.pptx
@@ -172,9 +172,9 @@
           </c:marker>
           <c:cat>
             <c:strRef>
-              <c:f>Sheet1!$A$2:$A$9</c:f>
+              <c:f>Sheet1!$A$2:$A$10</c:f>
               <c:strCache>
-                <c:ptCount val="8"/>
+                <c:ptCount val="9"/>
                 <c:pt idx="0">
                   <c:v>도로접면</c:v>
                 </c:pt>
@@ -199,38 +199,44 @@
                 <c:pt idx="7">
                   <c:v>경사도</c:v>
                 </c:pt>
+                <c:pt idx="8">
+                  <c:v>유동인구</c:v>
+                </c:pt>
               </c:strCache>
             </c:strRef>
           </c:cat>
           <c:val>
             <c:numRef>
-              <c:f>Sheet1!$B$2:$B$9</c:f>
+              <c:f>Sheet1!$B$2:$B$10</c:f>
               <c:numCache>
                 <c:formatCode>General</c:formatCode>
-                <c:ptCount val="8"/>
+                <c:ptCount val="9"/>
                 <c:pt idx="0">
-                  <c:v>85.0</c:v>
+                  <c:v>85</c:v>
                 </c:pt>
                 <c:pt idx="1">
-                  <c:v>91.0</c:v>
+                  <c:v>91</c:v>
                 </c:pt>
                 <c:pt idx="2">
-                  <c:v>90.0</c:v>
+                  <c:v>90</c:v>
                 </c:pt>
                 <c:pt idx="3">
-                  <c:v>80.0</c:v>
+                  <c:v>80</c:v>
                 </c:pt>
                 <c:pt idx="4">
-                  <c:v>70.0</c:v>
+                  <c:v>70</c:v>
                 </c:pt>
                 <c:pt idx="5">
-                  <c:v>80.0</c:v>
+                  <c:v>80</c:v>
                 </c:pt>
                 <c:pt idx="6">
-                  <c:v>70.0</c:v>
+                  <c:v>70</c:v>
                 </c:pt>
                 <c:pt idx="7">
-                  <c:v>60.0</c:v>
+                  <c:v>60</c:v>
+                </c:pt>
+                <c:pt idx="8">
+                  <c:v>75</c:v>
                 </c:pt>
               </c:numCache>
             </c:numRef>
@@ -11787,6 +11793,201 @@
                   </a:tcPr>
                 </a:tc>
               </a:tr>
+              <a:tr h="429768">
+                <a:tc>
+                  <a:txBody>
+                    <a:bodyPr/>
+                    <a:lstStyle/>
+                    <a:p>
+                      <a:pPr indent="0" marL="0">
+                        <a:buNone/>
+                      </a:pPr>
+                      <a:r>
+                        <a:rPr>
+                          <a:solidFill/>
+                        </a:rPr>
+                        <a:t>⑨ 유동인구</a:t>
+                      </a:r>
+                      <a:endParaRPr lang="en-US" sz="950" dirty="0">
+                        <a:latin typeface="Malgun Gothic" charset="0"/>
+                        <a:ea typeface="Malgun Gothic" charset="0"/>
+                        <a:cs typeface="Malgun Gothic" charset="0"/>
+                      </a:endParaRPr>
+                    </a:p>
+                  </a:txBody>
+                  <a:tcPr marL="73152" marR="73152" marT="18288" marB="18288" anchor="ctr">
+                    <a:lnL w="6350" cap="flat" cmpd="sng" algn="ctr">
+                      <a:solidFill>
+                        <a:srgbClr val="D9DEE8"/>
+                      </a:solidFill>
+                      <a:prstDash val="solid"/>
+                      <a:round/>
+                      <a:headEnd type="none" w="med" len="med"/>
+                      <a:tailEnd type="none" w="med" len="med"/>
+                    </a:lnL>
+                    <a:lnR w="6350" cap="flat" cmpd="sng" algn="ctr">
+                      <a:solidFill>
+                        <a:srgbClr val="D9DEE8"/>
+                      </a:solidFill>
+                      <a:prstDash val="solid"/>
+                      <a:round/>
+                      <a:headEnd type="none" w="med" len="med"/>
+                      <a:tailEnd type="none" w="med" len="med"/>
+                    </a:lnR>
+                    <a:lnT w="6350" cap="flat" cmpd="sng" algn="ctr">
+                      <a:solidFill>
+                        <a:srgbClr val="D9DEE8"/>
+                      </a:solidFill>
+                      <a:prstDash val="solid"/>
+                      <a:round/>
+                      <a:headEnd type="none" w="med" len="med"/>
+                      <a:tailEnd type="none" w="med" len="med"/>
+                    </a:lnT>
+                    <a:lnB w="6350" cap="flat" cmpd="sng" algn="ctr">
+                      <a:solidFill>
+                        <a:srgbClr val="D9DEE8"/>
+                      </a:solidFill>
+                      <a:prstDash val="solid"/>
+                      <a:round/>
+                      <a:headEnd type="none" w="med" len="med"/>
+                      <a:tailEnd type="none" w="med" len="med"/>
+                    </a:lnB>
+                    <a:solidFill>
+                      <a:srgbClr val="F4F6FB"/>
+                    </a:solidFill>
+                  </a:tcPr>
+                </a:tc>
+                <a:tc>
+                  <a:txBody>
+                    <a:bodyPr/>
+                    <a:lstStyle/>
+                    <a:p>
+                      <a:pPr algn="ctr" indent="0" marL="0">
+                        <a:buNone/>
+                      </a:pPr>
+                      <a:r>
+                        <a:rPr lang="en-US" sz="950" b="1" dirty="0">
+                          <a:solidFill>
+                            <a:srgbClr val="6B7280"/>
+                          </a:solidFill>
+                          <a:latin typeface="Malgun Gothic" pitchFamily="34" charset="0"/>
+                          <a:ea typeface="Malgun Gothic" pitchFamily="34" charset="-122"/>
+                          <a:cs typeface="Malgun Gothic" pitchFamily="34" charset="-120"/>
+                        </a:rPr>
+                        <a:t/>
+                      </a:r>
+                      <a:endParaRPr lang="en-US" sz="950" dirty="0">
+                        <a:latin typeface="Malgun Gothic" charset="0"/>
+                        <a:ea typeface="Malgun Gothic" charset="0"/>
+                        <a:cs typeface="Malgun Gothic" charset="0"/>
+                      </a:endParaRPr>
+                    </a:p>
+                  </a:txBody>
+                  <a:tcPr marL="73152" marR="73152" marT="18288" marB="18288" anchor="ctr">
+                    <a:lnL w="6350" cap="flat" cmpd="sng" algn="ctr">
+                      <a:solidFill>
+                        <a:srgbClr val="D9DEE8"/>
+                      </a:solidFill>
+                      <a:prstDash val="solid"/>
+                      <a:round/>
+                      <a:headEnd type="none" w="med" len="med"/>
+                      <a:tailEnd type="none" w="med" len="med"/>
+                    </a:lnL>
+                    <a:lnR w="6350" cap="flat" cmpd="sng" algn="ctr">
+                      <a:solidFill>
+                        <a:srgbClr val="D9DEE8"/>
+                      </a:solidFill>
+                      <a:prstDash val="solid"/>
+                      <a:round/>
+                      <a:headEnd type="none" w="med" len="med"/>
+                      <a:tailEnd type="none" w="med" len="med"/>
+                    </a:lnR>
+                    <a:lnT w="6350" cap="flat" cmpd="sng" algn="ctr">
+                      <a:solidFill>
+                        <a:srgbClr val="D9DEE8"/>
+                      </a:solidFill>
+                      <a:prstDash val="solid"/>
+                      <a:round/>
+                      <a:headEnd type="none" w="med" len="med"/>
+                      <a:tailEnd type="none" w="med" len="med"/>
+                    </a:lnT>
+                    <a:lnB w="6350" cap="flat" cmpd="sng" algn="ctr">
+                      <a:solidFill>
+                        <a:srgbClr val="D9DEE8"/>
+                      </a:solidFill>
+                      <a:prstDash val="solid"/>
+                      <a:round/>
+                      <a:headEnd type="none" w="med" len="med"/>
+                      <a:tailEnd type="none" w="med" len="med"/>
+                    </a:lnB>
+                  </a:tcPr>
+                </a:tc>
+                <a:tc>
+                  <a:txBody>
+                    <a:bodyPr/>
+                    <a:lstStyle/>
+                    <a:p>
+                      <a:pPr indent="0" marL="0">
+                        <a:buNone/>
+                      </a:pPr>
+                      <a:r>
+                        <a:rPr lang="en-US" sz="950" dirty="0">
+                          <a:solidFill>
+                            <a:srgbClr val="333333"/>
+                          </a:solidFill>
+                          <a:latin typeface="Malgun Gothic" pitchFamily="34" charset="0"/>
+                          <a:ea typeface="Malgun Gothic" pitchFamily="34" charset="-122"/>
+                          <a:cs typeface="Malgun Gothic" pitchFamily="34" charset="-120"/>
+                        </a:rPr>
+                        <a:t/>
+                      </a:r>
+                      <a:endParaRPr lang="en-US" sz="950" dirty="0">
+                        <a:latin typeface="Malgun Gothic" charset="0"/>
+                        <a:ea typeface="Malgun Gothic" charset="0"/>
+                        <a:cs typeface="Malgun Gothic" charset="0"/>
+                      </a:endParaRPr>
+                    </a:p>
+                  </a:txBody>
+                  <a:tcPr marL="73152" marR="73152" marT="18288" marB="18288" anchor="ctr">
+                    <a:lnL w="6350" cap="flat" cmpd="sng" algn="ctr">
+                      <a:solidFill>
+                        <a:srgbClr val="D9DEE8"/>
+                      </a:solidFill>
+                      <a:prstDash val="solid"/>
+                      <a:round/>
+                      <a:headEnd type="none" w="med" len="med"/>
+                      <a:tailEnd type="none" w="med" len="med"/>
+                    </a:lnL>
+                    <a:lnR w="6350" cap="flat" cmpd="sng" algn="ctr">
+                      <a:solidFill>
+                        <a:srgbClr val="D9DEE8"/>
+                      </a:solidFill>
+                      <a:prstDash val="solid"/>
+                      <a:round/>
+                      <a:headEnd type="none" w="med" len="med"/>
+                      <a:tailEnd type="none" w="med" len="med"/>
+                    </a:lnR>
+                    <a:lnT w="6350" cap="flat" cmpd="sng" algn="ctr">
+                      <a:solidFill>
+                        <a:srgbClr val="D9DEE8"/>
+                      </a:solidFill>
+                      <a:prstDash val="solid"/>
+                      <a:round/>
+                      <a:headEnd type="none" w="med" len="med"/>
+                      <a:tailEnd type="none" w="med" len="med"/>
+                    </a:lnT>
+                    <a:lnB w="6350" cap="flat" cmpd="sng" algn="ctr">
+                      <a:solidFill>
+                        <a:srgbClr val="D9DEE8"/>
+                      </a:solidFill>
+                      <a:prstDash val="solid"/>
+                      <a:round/>
+                      <a:headEnd type="none" w="med" len="med"/>
+                      <a:tailEnd type="none" w="med" len="med"/>
+                    </a:lnB>
+                  </a:tcPr>
+                </a:tc>
+              </a:tr>
             </a:tbl>
           </a:graphicData>
         </a:graphic>

</xml_diff>